<commit_message>
Report polish, English narration, and clean notebook 01 run
- report: BGU logo on title page, Spring 2026, references moved off the
  cover, tighter abstract, bolded our three scalar models, added
  "Bottom line" summary and surrogate-model tie-in to the course text
  (Shlezinger & Eldar FnT monograph now cited)
- presentation: speaker notes rewritten in English (read-aloud style),
  closing slide ends with thanks only (recorded seminar, no Q&A),
  course-book citation fixed; SPEAKER_SCRIPT.pdf (EN, timed) replaces
  the Hebrew markdown script
- notebooks: re-executed 01 top-to-bottom for clean execution counts
  (results unchanged: ISTA -5.31 dB, FISTA -11.01 dB)

Co-Authored-By: Claude Fable 5 <noreply@anthropic.com>
</commit_message>
<xml_diff>
--- a/presentation/MBDL_Seminar_Final.pptx
+++ b/presentation/MBDL_Seminar_Final.pptx
@@ -517,7 +517,7 @@
           <a:lstStyle/>
           <a:p>
             <a:r>
-              <a:t>שלום לכולם, אנחנו איתי ברון ואיתי ויגמן. הפרויקט שלנו עוסק בשחזור אותות דלילים ובחישה דחוסה בגישה של למידה עמוקה מבוססת מודל. שאלת הליבה שלנו: כמה רחוק אפשר להגיע עם מבנה אלגוריתמי בלבד, ומתי חייבים גמישות נלמדת מהדאטה. נקודת המוצא היא המאמר HyperLISTA מ-NeurIPS 2021.</a:t>
+              <a:t>Hello everyone. We are Etay Baron and Etai Wigman, and this is our final project for the Model-Based Deep Learning course. Our topic is sparse recovery and compressed sensing, based on the NeurIPS 2021 paper 'Hyperparameter Tuning is All You Need for LISTA'. The core question that guides this talk is simple: how far can model-based structure take us — and when do we need data-driven flexibility?</a:t>
             </a:r>
           </a:p>
         </p:txBody>
@@ -587,7 +587,7 @@
           <a:lstStyle/>
           <a:p>
             <a:r>
-              <a:t>כאן התמונה המלאה על הבעיה הסינתטית. בגרף רואים NMSE כפונקציה של עומק. שיטות האימון משנות 3-4 דציבל בתוך משפחת LISTA — L2 הכי טוב, L3 נתקע ברמה מסוימת כי לשכבות מאוחרות אין תמריץ להשתפר. אבל ההיררכיה הגדולה נשארת: ALISTA מנצח את כל גרסאות LISTA עם 32 פרמטרים, ו-HyperLISTA מנצח את כולם עם 3. כשהנחות המודל נכונות — מבנה מנצח קיבולת.</a:t>
+              <a:t>Here is the full picture on the synthetic problem: NMSE as a function of depth. The training method matters — L2 is the best, and L3 gets stuck around layer eight, because later layers have no incentive to improve on what earlier layers already solved. But the big hierarchy remains: ALISTA beats every LISTA variant with 32 parameters, and HyperLISTA beats everyone with three. When the model assumptions hold, structure beats capacity.</a:t>
             </a:r>
           </a:p>
         </p:txBody>
@@ -657,7 +657,7 @@
           <a:lstStyle/>
           <a:p>
             <a:r>
-              <a:t>מפת ה-design space מסכמת את החלק הסינתטי: ציר X — מספר פרמטרים בסקלה לוגריתמית, ציר Y — שגיאת שחזור. הפינה השמאלית-תחתונה היא האידיאל. StepThresholdISTA שלנו — 32 סקלרים — יושב באזור מצוין ומנצח את LISTA עם פי 187 אלף פחות פרמטרים. HyperLISTA שובר את הסקלה לגמרי. המסר: בבעיות עם מבנה ידוע, תכנון חכם של מה לומדים שווה יותר מקיבולת.</a:t>
+              <a:t>This map summarizes the synthetic part. The x-axis is the number of parameters on a logarithmic scale; the y-axis is the reconstruction error; the bottom-left corner is the ideal. Our StepThresholdISTA, with 32 scalars, sits in an excellent spot and beats LISTA with 187,000 times fewer parameters. HyperLISTA breaks the scale entirely. The message: in problems with known structure, choosing what to learn matters more than raw capacity.</a:t>
             </a:r>
           </a:p>
         </p:txBody>
@@ -727,7 +727,7 @@
           <a:lstStyle/>
           <a:p>
             <a:r>
-              <a:t>עכשיו המבחן האמיתי — תמונות אמיתיות. עברנו לחישה דחוסה בפיקסלים על FashionMNIST: התמונה שטוחה לווקטור בממד 784, ומודדים רק רבע מהממד. אין צורך ב-DCT כי לתמונות רקע שחור והן דלילות בפיקסלים. והנה ההיפוך הדרמטי: כל השיטות המובנות קורסות — ALISTA ו-HyperLISTA גרועים אף מ-ISTA — בעוד LISTA-L2 מגיע ל-SSIM של 0.82. הסיבה: ההנחה של דלילות גאוסית i.i.d. פשוט לא נכונה לפיקסלים חסומים ומתואמים מרחבית. פריור שגוי גרוע מאין-פריור.</a:t>
+              <a:t>Now the real test — actual images. We moved to pixel-domain compressed sensing on Fashion-MNIST: the image is flattened into a 784-dimensional vector, and we measure only a quarter of that dimension. No transform is needed, because these images have a black background and are naturally sparse in pixels. And here the ranking flips completely. All the structured methods collapse — ALISTA and HyperLISTA do even worse than plain ISTA — while LISTA with deep supervision reaches an SSIM of 0.82. The reason: the assumption of i.i.d. Gaussian sparsity is simply wrong for bounded, spatially-correlated pixels. A wrong prior is worse than no prior.</a:t>
             </a:r>
           </a:p>
         </p:txBody>
@@ -797,7 +797,7 @@
           <a:lstStyle/>
           <a:p>
             <a:r>
-              <a:t>בדקנו את זה שיטתית על שני דאטהסטים ושני יחסי מדידה. מפת החום מציגה SSIM. על MNIST עם חצי מהמדידות — כולם סבירים, כי MNIST דליל באמת: 78 אחוז אפסים. ככל שמקשים — פחות מדידות או דאטה מרקמי יותר — השיטות המובנות מתדרדרות בחדות, בעוד LISTA-L2 נשאר מעל 0.82 בכל התרחישים. הפריור הדליל מתפרק בהדרגה כשהדאטה מתרחק מההנחות.</a:t>
+              <a:t>We tested this systematically over two datasets and two measurement ratios; the heatmap shows SSIM. On MNIST with half the measurements, every method does fine, because MNIST is genuinely sparse — about 78 percent of its pixels are zero. As the task gets harder — fewer measurements, or more textured data — the structured methods degrade sharply, while LISTA-L2 stays above 0.82 in every scenario. The sparse prior breaks down gradually as the data moves away from the assumptions.</a:t>
             </a:r>
           </a:p>
         </p:txBody>
@@ -867,7 +867,7 @@
           <a:lstStyle/>
           <a:p>
             <a:r>
-              <a:t>ההשוואה הוויזואלית ממחישה את המספרים. משמאל MNIST, מימין FashionMNIST, שניהם ברבע מהמדידות. שורת LISTA-L2 כמעט זהה למקור בשני המקרים. ALISTA ו-HyperLISTA מאפסים סיגנל אמיתי — הסף שמכויל לרעש גאוסי דליל מוחק את התמונה עצמה. רואים כאן ויזואלית מה זה אומר כשהפריור שגוי.</a:t>
+              <a:t>The visual comparison makes the numbers concrete. MNIST is on the left, Fashion-MNIST on the right, both with a quarter of the measurements. The LISTA-L2 row is almost identical to the originals in both cases. ALISTA and HyperLISTA literally erase real signal — a threshold calibrated for sparse Gaussian residuals deletes the image itself. This is what a wrong prior looks like.</a:t>
             </a:r>
           </a:p>
         </p:txBody>
@@ -937,7 +937,7 @@
           <a:lstStyle/>
           <a:p>
             <a:r>
-              <a:t>לסיכום, ארבעה לקחים: אחד — כשההנחות מתקיימות, מבנה מנצח: 3 סקלרים מנצחים 6 מיליון פרמטרים ב-41 דציבל. שתיים — לוח הצעדים הוא הרכיב הכי חשוב ללמידה. שלוש — קשירת משקולות היא רגולריזציה מובנית. ארבע — פריור שגוי מזיק יותר מאין-פריור: על תמונות אמיתיות LISTA הגמיש מנצח. בהמשך נרצה לבדוק את המודלים בדומיין DCT או wavelets, שם התמונות קרובות יותר להנחת הדלילות הגאוסית.</a:t>
+              <a:t>To summarize, four lessons. One: when the assumptions hold, structure wins — three scalars beat six million parameters by 41 dB. Two: the step-size schedule is the most valuable thing to learn. Three: weight tying is implicit regularization. Four: a wrong prior actively hurts — on real images, the flexible LISTA wins. As future work, we would like to test these models in the DCT or wavelet domain, where images are much closer to the Gaussian-sparse assumption.</a:t>
             </a:r>
           </a:p>
         </p:txBody>
@@ -1007,7 +1007,7 @@
           <a:lstStyle/>
           <a:p>
             <a:r>
-              <a:t>כל הקוד, ארבעת המחברות והמודולים זמינים בריפו ציבורי בגיטהאב. אלו המקורות המרכזיים שעליהם התבססנו. תודה רבה על ההקשבה — נשמח לשאלות.</a:t>
+              <a:t>All of our code — the four notebooks and the source modules — is available in a public GitHub repository, and these are the main references we built on. Thank you very much for listening.</a:t>
             </a:r>
           </a:p>
         </p:txBody>
@@ -1077,7 +1077,7 @@
           <a:lstStyle/>
           <a:p>
             <a:r>
-              <a:t>מבנה ההרצאה: נתחיל ברקע — בעיית LASSO והאלגוריתמים הקלאסיים ISTA ו-FISTA. משם נעבור ל-Deep Unrolling: LISTA, ALISTA ו-HyperLISTA. החלק המרכזי הוא המחקר שלנו — אילו רכיבים של ISTA שווה ללמוד, והשוואת שיטות אימון לרשתות unfolded. נסיים בניסויי תמונות אמיתיות על MNIST ו-FashionMNIST בחישה דחוסה. הסטאפ הסינתטי: 250 מדידות, ממד 500, דלילות 50.</a:t>
+              <a:t>Here is the plan for the next fifteen minutes. We start with the background: the sparse recovery problem, the LASSO formulation, and the classical ISTA and FISTA algorithms. We then move to deep unrolling — LISTA, ALISTA, and HyperLISTA. The central part is our own study: we ask which components of ISTA are actually worth learning, and we compare the training methods for unfolded optimizers that were discussed in class. Finally, we stress-test everything on real images — MNIST and Fashion-MNIST — under compressed sensing. Our synthetic setup uses 250 measurements, signal dimension 500, and sparsity 50.</a:t>
             </a:r>
           </a:p>
         </p:txBody>
@@ -1147,7 +1147,7 @@
           <a:lstStyle/>
           <a:p>
             <a:r>
-              <a:t>בעיית השחזור: יש לנו וקטור דליל x כוכב בממד n, ואנחנו רואים רק m מדידות לינאריות, m קטן מ-n, עם רעש אפשרי. הבעיה לא מוגדרת היטב — יש אינסוף פתרונות — אבל הנחת הדלילות הופכת אותה לפתירה. זה מופיע בכל מקום: MRI, מכ"ם, חישה דחוסה. הפורמליזציה הסטנדרטית היא LASSO: איזון בין נאמנות למדידות לבין נורמת L1 שמעודדת דלילות. המדדים שלנו: NMSE בדציבלים לאותות סינתטיים, ובנוסף PSNR ו-SSIM לתמונות.</a:t>
+              <a:t>Let us define the problem. We want to recover a sparse vector x-star of dimension n, but we only observe m linear measurements, with m smaller than n, possibly with noise. This inverse problem is underdetermined — infinitely many signals explain the same measurements. The sparsity assumption is what makes it solvable, and this situation appears everywhere: MRI acceleration, radar, hyperspectral imaging. The standard formulation is the LASSO: a trade-off between fidelity to the measurements and an L1 norm that promotes sparsity. Our metrics are NMSE in decibels for synthetic signals, plus PSNR and SSIM for images.</a:t>
             </a:r>
           </a:p>
         </p:txBody>
@@ -1217,7 +1217,7 @@
           <a:lstStyle/>
           <a:p>
             <a:r>
-              <a:t>ISTA הוא gradient descent פרוקסימלי על LASSO: צעד גרדיאנט על איבר הנאמנות, ואז soft-thresholding שמאפס רכיבים קטנים. FISTA מוסיף מומנטום של נסטרוב ומשפר את קצב ההתכנסות מסדר 1 חלקי k לסדר 1 חלקי k בריבוע. אבל שימו לב לנקודה המרכזית: אחרי 16 איטרציות בלבד ISTA מגיע רק למינוס 5.3 דציבל ו-FISTA למינוס 11. כדי להגיע למינוס 20 צריך מאות איטרציות. השאלה: איך גורמים ל-16 צעדים באמת לעבוד?</a:t>
+              <a:t>ISTA is proximal gradient descent on the LASSO objective. Each iteration takes a gradient step on the data-fidelity term, and then applies soft-thresholding, which shrinks small entries to zero. FISTA adds Nesterov momentum and improves the convergence rate from order one-over-k to one-over-k-squared. But here is the key point: after only sixteen iterations, ISTA reaches just minus 5.3 dB, and FISTA minus 11. Reaching minus 20 dB takes hundreds of iterations. So the question is: how do we make sixteen steps really count?</a:t>
             </a:r>
           </a:p>
         </p:txBody>
@@ -1287,7 +1287,7 @@
           <a:lstStyle/>
           <a:p>
             <a:r>
-              <a:t>הרעיון של Gregor ו-LeCun מ-2010: לפרוש את K האיטרציות של ISTA לרשת בעומק K, ולהפוך את הקבועים האלגוריתמיים לפרמטרים נלמדים. משמאל — ISTA קלאסי עם צעד ו-threshold קבועים. מימין — LISTA: שתי מטריצות משקל ו-threshold נפרד לכל שכבה, הכל נלמד ב-backpropagation מזוגות אימון. זה העיקרון של למידה מבוססת מודל: שומרים על המבנה — צעד גרדיאנט ואז soft-threshold — ולומדים רק את מה שמשפר שחזור בעומק סופי. בסטאפ שלנו זה כ-6 מיליון פרמטרים.</a:t>
+              <a:t>The idea, due to Gregor and LeCun in 2010, is to unfold the K iterations of ISTA into a network with K layers, and to turn the algorithmic constants into learnable parameters. On the left you see classical ISTA, with a fixed step size and a fixed threshold. On the right is LISTA: two weight matrices and a separate threshold per layer, all trained end-to-end with backpropagation. This is the model-based deep learning principle: keep the structure — a gradient step followed by soft-thresholding — and learn only what improves reconstruction at a finite depth. In our setting this amounts to about six million parameters.</a:t>
             </a:r>
           </a:p>
         </p:txBody>
@@ -1357,7 +1357,7 @@
           <a:lstStyle/>
           <a:p>
             <a:r>
-              <a:t>עכשיו סולם ה-MBDL — פחות פרמטרים, יותר מבנה. LISTA לומד הכל: 6 מיליון פרמטרים ומגיע למינוס 20 דציבל. ALISTA מראה שאפשר לחשב את מטריצת המשקל אנליטית מ-A — פתרון בעיית מזעור קוהרנטיות — ולהשאיר ללמידה רק צעדים ו-thresholds: 32 פרמטרים, מינוס 30 דציבל. HyperLISTA לוקח את זה לקצה: שלושה סקלרים בלבד. ה-threshold, המומנטום ובחירת התומך מחושבים אדפטיבית מהשארית בכל שכבה, לפי הנוסחאות שמוצגות. שימו לב — אין בכלל backpropagation: שלושת הסקלרים נמצאים ב-grid search. והתוצאה: מינוס 61 דציבל, הטובה ביותר. יותר מבנה, פחות פרמטרים, ביצועים טובים יותר — זה עקרון ה-MBDL בפעולה.</a:t>
+              <a:t>Now the MBDL ladder — more structure, fewer parameters. LISTA learns everything: six million parameters, minus 20 dB. ALISTA shows that the weight matrix does not need to be learned at all: it can be computed analytically from A, leaving only per-layer step sizes and thresholds — 32 parameters, and minus 30 dB. HyperLISTA takes this to the extreme: only three scalars. The threshold, the momentum, and the support selection are computed adaptively from the residual at every layer, using the formulas on the slide. And notice — there is no backpropagation at all: the three scalars are found by a simple grid search. The result: minus 61 dB, the best of all. More structure, fewer parameters, better performance — this is the MBDL principle in action.</a:t>
             </a:r>
           </a:p>
         </p:txBody>
@@ -1427,7 +1427,7 @@
           <a:lstStyle/>
           <a:p>
             <a:r>
-              <a:t>זה מוביל לשאלת המחקר שלנו: בין 6 מיליון לשלושה פרמטרים — מה המינימום שבאמת צריך ללמוד? עדכון ISTA המוכלל חושף שתי סדרות סקלרים חופשיות: גודל הצעד גמא והסף תטא. בנינו שלושה מודלים: ThresholdISTA שלומד רק את הספים, StepISTA שלומד רק את הצעדים כשהסף צמוד אליהם, ו-StepThresholdISTA שלומד את שניהם בנפרד — 32 סקלרים בסך הכל. כולם מאותחלים לערכי ISTA המדויקים, כך שלפני האימון הם זהים ל-ISTA.</a:t>
+              <a:t>This leads to our research question: between six million parameters and three, what is the minimal set that is actually worth learning? The generalized ISTA update exposes two free scalar sequences: the step size gamma and the threshold theta. We designed three models. ThresholdISTA learns only the thresholds. StepISTA learns only the step sizes, with the threshold tied to them. And StepThresholdISTA learns both, independently — 32 scalars in total. All of them are initialized to the exact ISTA values, so before training, every model is identical to ISTA.</a:t>
             </a:r>
           </a:p>
         </p:txBody>
@@ -1497,7 +1497,7 @@
           <a:lstStyle/>
           <a:p>
             <a:r>
-              <a:t>התוצאות מפתיעות בעוצמתן. ThresholdISTA — לימוד ספים בלבד — כמעט לא עוזר: מינוס 7 דציבל. אבל StepISTA — לימוד לוחות הצעדים בלבד, 16 סקלרים — קופץ למינוס 20 דציבל ומשתווה ל-LISTA המלא עם 6 מיליון פרמטרים. הפרדת הסף מהצעד מוסיפה עוד 3 דציבל בחינם. המסקנה: לוח הצעדים הוא הרכיב הקריטי ללמידה בעומק סופי, ולמידת מטריצות מלאות היא בעיקרה מיותרת כשמטריצת המדידה קבועה.</a:t>
+              <a:t>The results are quite striking. Learning thresholds alone barely helps: minus 7 dB. But learning the step-size schedule alone — just sixteen scalars — jumps to minus 20 dB and matches the full LISTA with six million parameters. Decoupling the threshold from the step adds another 3.6 dB, essentially for free. The conclusion: the step-size schedule is the critical component to learn at finite depth, and learning full matrices is largely redundant when the sensing matrix is fixed.</a:t>
             </a:r>
           </a:p>
         </p:txBody>
@@ -1567,7 +1567,7 @@
           <a:lstStyle/>
           <a:p>
             <a:r>
-              <a:t>בהתאם להמלצת המרצה, השווינו גם את שיטות האימון מההרצאות לאותה ארכיטקטורה בדיוק. L1 — אימון end-to-end עם loss על השכבה האחרונה. L2 — deep supervision עם loss משוקלל על כל שכבת ביניים. L3 — אימון חמדני שכבה-שכבה כשהקודמות מוקפאות. בנוסף בדקנו קשירת משקולות — אותה שכבה חוזרת K פעמים, כמו RNN. הממצא המעניין: LISTA קשור עם פי 16 פחות פרמטרים מגיע כמעט לאותה תוצאה — קשירת משקולות היא רגולריזציה מובנית.</a:t>
+              <a:t>Following the training strategies discussed in class, we compared them on the exact same architecture. L1 is standard end-to-end training, with a loss on the final layer only. L2 is deep supervision: a weighted loss on every intermediate layer. L3 is greedy layer-wise training, where each layer is trained while the previous ones are frozen. We also tested weight tying — the same layer repeated K times, like a recurrent network. The interesting finding: tied LISTA, with sixteen times fewer parameters, comes very close to the untied version. Weight tying acts as a built-in regularizer.</a:t>
             </a:r>
           </a:p>
         </p:txBody>
@@ -11332,7 +11332,7 @@
                 </a:solidFill>
                 <a:latin typeface="Calibri"/>
               </a:rPr>
-              <a:t>[6]  N. Shlezinger, J. Whang, Y. C. Eldar, A. G. Dimakis, "Model-Based Deep Learning," Proceedings of the IEEE, 2023.</a:t>
+              <a:t>[6]  N. Shlezinger and Y. C. Eldar, "Model-Based Deep Learning," Foundations and Trends in Signal Processing, vol. 17, no. 4, 2023.</a:t>
             </a:r>
           </a:p>
         </p:txBody>
@@ -11402,7 +11402,7 @@
                 </a:solidFill>
                 <a:latin typeface="Calibri"/>
               </a:rPr>
-              <a:t>Thank you!  Questions welcome.</a:t>
+              <a:t>Thank you very much for listening!</a:t>
             </a:r>
           </a:p>
         </p:txBody>

</xml_diff>